<commit_message>
Update powerpoint to reflect new fairness audit figures
</commit_message>
<xml_diff>
--- a/docs/Employee_Retention_Predictor_Capstone_Presentation.pptx
+++ b/docs/Employee_Retention_Predictor_Capstone_Presentation.pptx
@@ -8,8 +8,8 @@
     <p:notesMasterId r:id="rId16"/>
   </p:notesMasterIdLst>
   <p:sldIdLst>
-    <p:sldId id="256" r:id="rId2"/>
-    <p:sldId id="257" r:id="rId3"/>
+    <p:sldId id="257" r:id="rId2"/>
+    <p:sldId id="256" r:id="rId3"/>
     <p:sldId id="258" r:id="rId4"/>
     <p:sldId id="259" r:id="rId5"/>
     <p:sldId id="260" r:id="rId6"/>
@@ -125,17 +125,25 @@
 </p:presentation>
 </file>
 
+<file path=ppt/revisionInfo.xml><?xml version="1.0" encoding="utf-8"?>
+<p1510:revInfo xmlns:a="http://schemas.openxmlformats.org/drawingml/2006/main" xmlns:r="http://schemas.openxmlformats.org/officeDocument/2006/relationships" xmlns:p1510="http://schemas.microsoft.com/office/powerpoint/2015/10/main">
+  <p1510:revLst>
+    <p1510:client id="{6E3CE78C-DD8A-40F7-B278-8310FFAF2213}" v="16" dt="2026-09-11T19:39:24.306"/>
+  </p1510:revLst>
+</p1510:revInfo>
+</file>
+
 <file path=ppt/changesInfos/changesInfo1.xml><?xml version="1.0" encoding="utf-8"?>
 <pc:chgInfo xmlns:a="http://schemas.openxmlformats.org/drawingml/2006/main" xmlns:r="http://schemas.openxmlformats.org/officeDocument/2006/relationships" xmlns:ac="http://schemas.microsoft.com/office/drawing/2013/main/command" xmlns:pc="http://schemas.microsoft.com/office/powerpoint/2013/main/command">
   <pc:docChgLst>
     <pc:chgData name="Wouter Roos" userId="239c5a57-57c8-499d-8a57-5e4ac9b5fba6" providerId="ADAL" clId="{192D8F60-AF15-4EDB-814F-22369D656A18}"/>
-    <pc:docChg chg="undo custSel modSld">
-      <pc:chgData name="Wouter Roos" userId="239c5a57-57c8-499d-8a57-5e4ac9b5fba6" providerId="ADAL" clId="{192D8F60-AF15-4EDB-814F-22369D656A18}" dt="2026-09-11T13:32:25.786" v="46" actId="478"/>
+    <pc:docChg chg="undo custSel modSld sldOrd">
+      <pc:chgData name="Wouter Roos" userId="239c5a57-57c8-499d-8a57-5e4ac9b5fba6" providerId="ADAL" clId="{192D8F60-AF15-4EDB-814F-22369D656A18}" dt="2026-09-11T19:40:05.817" v="6379" actId="20577"/>
       <pc:docMkLst>
         <pc:docMk/>
       </pc:docMkLst>
-      <pc:sldChg chg="addSp delSp modSp mod">
-        <pc:chgData name="Wouter Roos" userId="239c5a57-57c8-499d-8a57-5e4ac9b5fba6" providerId="ADAL" clId="{192D8F60-AF15-4EDB-814F-22369D656A18}" dt="2026-09-11T13:32:21.337" v="45" actId="22"/>
+      <pc:sldChg chg="addSp delSp modSp mod modNotesTx">
+        <pc:chgData name="Wouter Roos" userId="239c5a57-57c8-499d-8a57-5e4ac9b5fba6" providerId="ADAL" clId="{192D8F60-AF15-4EDB-814F-22369D656A18}" dt="2026-09-11T16:12:54.273" v="1224" actId="33524"/>
         <pc:sldMkLst>
           <pc:docMk/>
           <pc:sldMk cId="0" sldId="256"/>
@@ -221,8 +229,8 @@
           </ac:picMkLst>
         </pc:picChg>
       </pc:sldChg>
-      <pc:sldChg chg="addSp delSp modSp mod">
-        <pc:chgData name="Wouter Roos" userId="239c5a57-57c8-499d-8a57-5e4ac9b5fba6" providerId="ADAL" clId="{192D8F60-AF15-4EDB-814F-22369D656A18}" dt="2026-09-11T13:32:25.786" v="46" actId="478"/>
+      <pc:sldChg chg="addSp delSp modSp mod ord modNotesTx">
+        <pc:chgData name="Wouter Roos" userId="239c5a57-57c8-499d-8a57-5e4ac9b5fba6" providerId="ADAL" clId="{192D8F60-AF15-4EDB-814F-22369D656A18}" dt="2026-09-11T16:08:26.830" v="1002" actId="20577"/>
         <pc:sldMkLst>
           <pc:docMk/>
           <pc:sldMk cId="0" sldId="257"/>
@@ -236,8 +244,8 @@
           </ac:picMkLst>
         </pc:picChg>
       </pc:sldChg>
-      <pc:sldChg chg="addSp delSp modSp mod">
-        <pc:chgData name="Wouter Roos" userId="239c5a57-57c8-499d-8a57-5e4ac9b5fba6" providerId="ADAL" clId="{192D8F60-AF15-4EDB-814F-22369D656A18}" dt="2026-09-11T13:32:20.684" v="43" actId="22"/>
+      <pc:sldChg chg="addSp delSp modSp mod modNotesTx">
+        <pc:chgData name="Wouter Roos" userId="239c5a57-57c8-499d-8a57-5e4ac9b5fba6" providerId="ADAL" clId="{192D8F60-AF15-4EDB-814F-22369D656A18}" dt="2026-09-11T16:20:58.564" v="2609" actId="20577"/>
         <pc:sldMkLst>
           <pc:docMk/>
           <pc:sldMk cId="0" sldId="258"/>
@@ -251,8 +259,8 @@
           </ac:picMkLst>
         </pc:picChg>
       </pc:sldChg>
-      <pc:sldChg chg="addSp delSp modSp mod">
-        <pc:chgData name="Wouter Roos" userId="239c5a57-57c8-499d-8a57-5e4ac9b5fba6" providerId="ADAL" clId="{192D8F60-AF15-4EDB-814F-22369D656A18}" dt="2026-09-11T13:32:20.029" v="41" actId="22"/>
+      <pc:sldChg chg="addSp delSp modSp mod modNotesTx">
+        <pc:chgData name="Wouter Roos" userId="239c5a57-57c8-499d-8a57-5e4ac9b5fba6" providerId="ADAL" clId="{192D8F60-AF15-4EDB-814F-22369D656A18}" dt="2026-09-11T16:30:41.425" v="3937" actId="20577"/>
         <pc:sldMkLst>
           <pc:docMk/>
           <pc:sldMk cId="0" sldId="259"/>
@@ -265,6 +273,42 @@
             <ac:picMk id="34" creationId="{A201A770-74CA-AB3D-0EBD-A30BC830FCF6}"/>
           </ac:picMkLst>
         </pc:picChg>
+      </pc:sldChg>
+      <pc:sldChg chg="modNotesTx">
+        <pc:chgData name="Wouter Roos" userId="239c5a57-57c8-499d-8a57-5e4ac9b5fba6" providerId="ADAL" clId="{192D8F60-AF15-4EDB-814F-22369D656A18}" dt="2026-09-11T16:37:23.810" v="4751" actId="20577"/>
+        <pc:sldMkLst>
+          <pc:docMk/>
+          <pc:sldMk cId="0" sldId="260"/>
+        </pc:sldMkLst>
+      </pc:sldChg>
+      <pc:sldChg chg="modNotesTx">
+        <pc:chgData name="Wouter Roos" userId="239c5a57-57c8-499d-8a57-5e4ac9b5fba6" providerId="ADAL" clId="{192D8F60-AF15-4EDB-814F-22369D656A18}" dt="2026-09-11T16:49:25.567" v="5987" actId="20577"/>
+        <pc:sldMkLst>
+          <pc:docMk/>
+          <pc:sldMk cId="0" sldId="261"/>
+        </pc:sldMkLst>
+      </pc:sldChg>
+      <pc:sldChg chg="modNotesTx">
+        <pc:chgData name="Wouter Roos" userId="239c5a57-57c8-499d-8a57-5e4ac9b5fba6" providerId="ADAL" clId="{192D8F60-AF15-4EDB-814F-22369D656A18}" dt="2026-09-11T17:03:24.626" v="6297" actId="20577"/>
+        <pc:sldMkLst>
+          <pc:docMk/>
+          <pc:sldMk cId="0" sldId="262"/>
+        </pc:sldMkLst>
+      </pc:sldChg>
+      <pc:sldChg chg="modSp mod modNotesTx">
+        <pc:chgData name="Wouter Roos" userId="239c5a57-57c8-499d-8a57-5e4ac9b5fba6" providerId="ADAL" clId="{192D8F60-AF15-4EDB-814F-22369D656A18}" dt="2026-09-11T19:40:05.817" v="6379" actId="20577"/>
+        <pc:sldMkLst>
+          <pc:docMk/>
+          <pc:sldMk cId="0" sldId="263"/>
+        </pc:sldMkLst>
+        <pc:spChg chg="mod">
+          <ac:chgData name="Wouter Roos" userId="239c5a57-57c8-499d-8a57-5e4ac9b5fba6" providerId="ADAL" clId="{192D8F60-AF15-4EDB-814F-22369D656A18}" dt="2026-09-11T19:39:07.813" v="6350" actId="20577"/>
+          <ac:spMkLst>
+            <pc:docMk/>
+            <pc:sldMk cId="0" sldId="263"/>
+            <ac:spMk id="10" creationId="{00000000-0000-0000-0000-000000000000}"/>
+          </ac:spMkLst>
+        </pc:spChg>
       </pc:sldChg>
     </pc:docChg>
   </pc:docChgLst>
@@ -440,6 +484,10 @@
           <a:bodyPr/>
           <a:lstStyle/>
           <a:p>
+            <a:r>
+              <a:rPr lang="en-ZA" dirty="0"/>
+              <a:t>I'm Philip Roos. During this engagement, I've focused on one core question: can we identify the people about to leave Helix before they hand in their notice?</a:t>
+            </a:r>
             <a:endParaRPr lang="en-US" dirty="0"/>
           </a:p>
         </p:txBody>
@@ -944,6 +992,10 @@
           <a:bodyPr/>
           <a:lstStyle/>
           <a:p>
+            <a:r>
+              <a:rPr lang="en-ZA" dirty="0"/>
+              <a:t>I am presenting today to the Helix executive committee: our CHRO, our Finance Director, and our VP of Engineering. My goal is to secure one hundred and eighty-five thousand dollars for Phase 1. However, I am asking you to keep the actual intervention budget locked down until we pass two specific validation gates. Here is why.</a:t>
+            </a:r>
             <a:endParaRPr lang="en-US" dirty="0"/>
           </a:p>
         </p:txBody>
@@ -1028,6 +1080,10 @@
           <a:bodyPr/>
           <a:lstStyle/>
           <a:p>
+            <a:r>
+              <a:rPr lang="en-ZA" dirty="0"/>
+              <a:t>Last year, we lost two hundred and thirty-seven people, or sixteen percent of our workforce. Applying the industry-standard replacement cost of one and a half times salary, that is twenty point four million dollars walking out the door. The real issue is how we spent that money. We paid recruiters and absorbed vacancy gaps reactively, long after the employee decided to leave. This hurts us deeply because sixty-five percent of our staff are in R&amp;D. Our regulatory depth and integrated technology stack degrade the moment an engineer leaves. Since half of departing tech talent goes to competitors, a huge chunk of that twenty million dollars is actively funding our competition.</a:t>
+            </a:r>
             <a:endParaRPr lang="en-US" dirty="0"/>
           </a:p>
         </p:txBody>
@@ -1112,6 +1168,10 @@
           <a:bodyPr/>
           <a:lstStyle/>
           <a:p>
+            <a:r>
+              <a:rPr lang="en-ZA" dirty="0"/>
+              <a:t>It is easy to assume this is just a compensation issue, but the data says otherwise. Workload is a massive factor. Employees putting in sustained overtime leave at a rate of thirty point five percent, compared to ten point four percent for those working standard hours. We also see first-year employees leaving at thirty-five percent, and employees adjusting to a new manager leaving at thirty-two percent. These are timing problems, not pay scale problems. Our HR process only kicks in at resignation, exactly when we lose our leverage. Without a ranked list of who is actually at risk, we either spread our retention budget too thin or rely on managerial gut feeling. We have a targeting problem.</a:t>
+            </a:r>
             <a:endParaRPr lang="en-US" dirty="0"/>
           </a:p>
         </p:txBody>
@@ -1196,6 +1256,10 @@
           <a:bodyPr/>
           <a:lstStyle/>
           <a:p>
+            <a:r>
+              <a:rPr lang="en-ZA" dirty="0"/>
+              <a:t>I want to be very clear about what we built here. Think about how we run condition monitoring on our plant compressors. A vibration sensor doesn't fix a broken bearing. It gives you the lead time to do the maintenance. This predictive model is the sensor. It scores every employee's propensity to leave, ranks them, and isolates the specific drivers pushing that score up. It buys us lead time. The model does not retain anyone. The conversation HR has with that employee is what retains them. That distinction drives my final recommendation.</a:t>
+            </a:r>
             <a:endParaRPr lang="en-US" dirty="0"/>
           </a:p>
         </p:txBody>
@@ -1280,6 +1344,10 @@
           <a:bodyPr/>
           <a:lstStyle/>
           <a:p>
+            <a:r>
+              <a:rPr lang="en-ZA" dirty="0"/>
+              <a:t>We didn't launch any new surveys for this. We used thirty-five existing fields from our HRIS. Interestingly, no single variable acts as a perfect predictor. But when we combine these variables, the signal becomes incredibly clear. A standard dashboard will tell you high overtime is bad. This model will tell you that a specific engineer with high overtime, a recent manager change, and no stock options represents an eighty-six thousand dollar flight risk liability. One thing that surprised me was promotion stagnation. In the raw numbers, it doesn't look like a flight risk. But people who haven't been promoted recently also tend to be our most tenured staff, which protects against attrition. Once the model controls for tenure, promotion stagnation lights up as a major risk driver.</a:t>
+            </a:r>
             <a:endParaRPr lang="en-US" dirty="0"/>
           </a:p>
         </p:txBody>
@@ -1364,6 +1432,146 @@
           <a:bodyPr/>
           <a:lstStyle/>
           <a:p>
+            <a:pPr rtl="0"/>
+            <a:r>
+              <a:rPr lang="en-ZA" dirty="0"/>
+              <a:t>Now, does it actually work? I rigorously validated the model. Let me explain how.</a:t>
+            </a:r>
+          </a:p>
+          <a:p>
+            <a:pPr rtl="0"/>
+            <a:endParaRPr lang="en-ZA" dirty="0"/>
+          </a:p>
+          <a:p>
+            <a:pPr rtl="0"/>
+            <a:r>
+              <a:rPr lang="en-ZA" dirty="0"/>
+              <a:t>The easy approach is to split your data, tune on one half, report on the other. </a:t>
+            </a:r>
+          </a:p>
+          <a:p>
+            <a:pPr rtl="0"/>
+            <a:r>
+              <a:rPr lang="en-ZA" dirty="0"/>
+              <a:t>I did that at first, and it was wrong – I tuned my decision threshold on the same data I was reporting from, which subsequently inflates every number.</a:t>
+            </a:r>
+          </a:p>
+          <a:p>
+            <a:pPr rtl="0"/>
+            <a:endParaRPr lang="en-ZA" dirty="0"/>
+          </a:p>
+          <a:p>
+            <a:pPr rtl="0"/>
+            <a:r>
+              <a:rPr lang="en-ZA" dirty="0"/>
+              <a:t>So I rebuilt it with nested cross-validation. </a:t>
+            </a:r>
+          </a:p>
+          <a:p>
+            <a:pPr rtl="0"/>
+            <a:r>
+              <a:rPr lang="en-ZA" dirty="0"/>
+              <a:t>The threshold is chosen inside an inner loop, then tested on data that loop never saw. </a:t>
+            </a:r>
+          </a:p>
+          <a:p>
+            <a:pPr rtl="0"/>
+            <a:r>
+              <a:rPr lang="en-ZA" dirty="0"/>
+              <a:t>Every one of our fourteen hundred and seventy employees gets an honest, out-of-sample score.</a:t>
+            </a:r>
+          </a:p>
+          <a:p>
+            <a:pPr rtl="0"/>
+            <a:endParaRPr lang="en-ZA" dirty="0"/>
+          </a:p>
+          <a:p>
+            <a:pPr rtl="0"/>
+            <a:r>
+              <a:rPr lang="en-ZA" dirty="0"/>
+              <a:t>The result: </a:t>
+            </a:r>
+            <a:r>
+              <a:rPr lang="en-ZA" b="1" dirty="0"/>
+              <a:t>Area Under Curve of zero point eight one three</a:t>
+            </a:r>
+            <a:r>
+              <a:rPr lang="en-ZA" dirty="0"/>
+              <a:t>. </a:t>
+            </a:r>
+          </a:p>
+          <a:p>
+            <a:pPr rtl="0"/>
+            <a:r>
+              <a:rPr lang="en-ZA" dirty="0"/>
+              <a:t>We catch </a:t>
+            </a:r>
+            <a:r>
+              <a:rPr lang="en-ZA" b="1" dirty="0"/>
+              <a:t>sixty-five percent of people who subsequently left</a:t>
+            </a:r>
+            <a:r>
+              <a:rPr lang="en-ZA" dirty="0"/>
+              <a:t>, and </a:t>
+            </a:r>
+            <a:r>
+              <a:rPr lang="en-ZA" b="1" dirty="0"/>
+              <a:t>forty-three percent of everyone we flag is genuine</a:t>
+            </a:r>
+            <a:r>
+              <a:rPr lang="en-ZA" dirty="0"/>
+              <a:t>. </a:t>
+            </a:r>
+          </a:p>
+          <a:p>
+            <a:pPr rtl="0"/>
+            <a:r>
+              <a:rPr lang="en-ZA" dirty="0"/>
+              <a:t>Roughly one in two conversations is with a real flight risk.</a:t>
+            </a:r>
+          </a:p>
+          <a:p>
+            <a:pPr rtl="0"/>
+            <a:endParaRPr lang="en-ZA" dirty="0"/>
+          </a:p>
+          <a:p>
+            <a:pPr rtl="0"/>
+            <a:r>
+              <a:rPr lang="en-ZA" dirty="0"/>
+              <a:t>And because it's validated across two hundred and thirty-seven departures rather than the forty-seven you'd get from a single holdout, the confidence interval on that recall figure is roughly half as wide. </a:t>
+            </a:r>
+          </a:p>
+          <a:p>
+            <a:pPr rtl="0"/>
+            <a:r>
+              <a:rPr lang="en-ZA" dirty="0"/>
+              <a:t>That's the difference between a number you can budget against and a number you can only gesture at.</a:t>
+            </a:r>
+          </a:p>
+          <a:p>
+            <a:pPr rtl="0"/>
+            <a:endParaRPr lang="en-ZA" dirty="0"/>
+          </a:p>
+          <a:p>
+            <a:pPr rtl="0"/>
+            <a:r>
+              <a:rPr lang="en-ZA" dirty="0"/>
+              <a:t>Lastly, I’ll briefly touch on model comparisons. </a:t>
+            </a:r>
+          </a:p>
+          <a:p>
+            <a:pPr rtl="0"/>
+            <a:r>
+              <a:rPr lang="en-ZA" dirty="0"/>
+              <a:t>I tested a random forest against a plain logistic regression. </a:t>
+            </a:r>
+          </a:p>
+          <a:p>
+            <a:pPr rtl="0"/>
+            <a:r>
+              <a:rPr lang="en-ZA" dirty="0"/>
+              <a:t>The simple model won – so every score can be explained to the employee it describes without sacrificing accuracy and predictive performance. </a:t>
+            </a:r>
             <a:endParaRPr lang="en-US" dirty="0"/>
           </a:p>
         </p:txBody>
@@ -1447,6 +1655,81 @@
         <p:txBody>
           <a:bodyPr/>
           <a:lstStyle/>
+          <a:p>
+            <a:pPr rtl="0"/>
+            <a:r>
+              <a:rPr lang="en-ZA" dirty="0"/>
+              <a:t>Before anyone asks the governance question – I've excluded gender, age and marital status entirely. </a:t>
+            </a:r>
+          </a:p>
+          <a:p>
+            <a:pPr rtl="0"/>
+            <a:endParaRPr lang="en-ZA" dirty="0"/>
+          </a:p>
+          <a:p>
+            <a:pPr rtl="0"/>
+            <a:r>
+              <a:rPr lang="en-ZA" dirty="0"/>
+              <a:t>That costs us about a one point one hundredths or one percent of predictive performance. </a:t>
+            </a:r>
+          </a:p>
+          <a:p>
+            <a:pPr rtl="0"/>
+            <a:r>
+              <a:rPr lang="en-ZA" dirty="0"/>
+              <a:t>I'll take that trade every time.</a:t>
+            </a:r>
+          </a:p>
+          <a:p>
+            <a:pPr rtl="0"/>
+            <a:endParaRPr lang="en-ZA" dirty="0"/>
+          </a:p>
+          <a:p>
+            <a:pPr rtl="0"/>
+            <a:r>
+              <a:rPr lang="en-ZA" dirty="0"/>
+              <a:t>I also excluded commute distance, which is the interesting one. </a:t>
+            </a:r>
+          </a:p>
+          <a:p>
+            <a:pPr rtl="0"/>
+            <a:r>
+              <a:rPr lang="en-ZA" dirty="0"/>
+              <a:t>The Chief HR Officer asked for a commute threshold to trigger hybrid-working policy. </a:t>
+            </a:r>
+          </a:p>
+          <a:p>
+            <a:pPr rtl="0"/>
+            <a:endParaRPr lang="en-ZA" dirty="0"/>
+          </a:p>
+          <a:p>
+            <a:pPr rtl="0"/>
+            <a:r>
+              <a:rPr lang="en-ZA" dirty="0"/>
+              <a:t>I am  NOT delivering it. </a:t>
+            </a:r>
+          </a:p>
+          <a:p>
+            <a:pPr rtl="0"/>
+            <a:r>
+              <a:rPr lang="en-ZA" dirty="0"/>
+              <a:t>Commute distance is a well-documented proxy for race through residential segregation, and I have no race data to test whether that proxy is active here. </a:t>
+            </a:r>
+          </a:p>
+          <a:p>
+            <a:pPr rtl="0"/>
+            <a:r>
+              <a:rPr lang="en-ZA" dirty="0"/>
+              <a:t>I'm not building a policy lever on an untestable proxy.</a:t>
+            </a:r>
+          </a:p>
+          <a:p>
+            <a:pPr rtl="0"/>
+            <a:r>
+              <a:rPr lang="en-ZA" dirty="0"/>
+              <a:t>Where I could test — gender — the impact ratio is zero point nine one. That passes the four-fifths rule comfortably. On live data we test every protected class before anyone is scored.</a:t>
+            </a:r>
+          </a:p>
           <a:p>
             <a:endParaRPr lang="en-US" dirty="0"/>
           </a:p>
@@ -1886,7 +2169,7 @@
 
 <file path=ppt/slides/slide1.xml><?xml version="1.0" encoding="utf-8"?>
 <p:sld xmlns:a="http://schemas.openxmlformats.org/drawingml/2006/main" xmlns:r="http://schemas.openxmlformats.org/officeDocument/2006/relationships" xmlns:p="http://schemas.openxmlformats.org/presentationml/2006/main">
-  <p:cSld name="Slide 1">
+  <p:cSld name="Slide 2">
     <p:bg>
       <p:bgPr>
         <a:solidFill>
@@ -1917,8 +2200,8 @@
         </p:nvSpPr>
         <p:spPr>
           <a:xfrm>
-            <a:off x="1238250" y="1047750"/>
-            <a:ext cx="17392650" cy="750540"/>
+            <a:off x="1238250" y="2076450"/>
+            <a:ext cx="14716125" cy="2602706"/>
           </a:xfrm>
           <a:prstGeom prst="rect">
             <a:avLst/>
@@ -1934,12 +2217,12 @@
           <a:p>
             <a:pPr marL="0" indent="0" algn="l">
               <a:lnSpc>
-                <a:spcPct val="97143"/>
-              </a:lnSpc>
-              <a:buNone/>
-            </a:pPr>
-            <a:r>
-              <a:rPr lang="en-US" sz="5100" kern="0" spc="-51" dirty="0">
+                <a:spcPct val="89760"/>
+              </a:lnSpc>
+              <a:buNone/>
+            </a:pPr>
+            <a:r>
+              <a:rPr lang="en-US" sz="9900" kern="0" spc="-247" dirty="0">
                 <a:solidFill>
                   <a:srgbClr val="F2EDE4"/>
                 </a:solidFill>
@@ -1947,9 +2230,9 @@
                 <a:ea typeface="Georgia" pitchFamily="34" charset="-122"/>
                 <a:cs typeface="Georgia" pitchFamily="34" charset="-120"/>
               </a:rPr>
-              <a:t>Context &amp; Objective</a:t>
-            </a:r>
-            <a:endParaRPr lang="en-US" sz="5100" dirty="0"/>
+              <a:t>The Employee Retention Predictor</a:t>
+            </a:r>
+            <a:endParaRPr lang="en-US" sz="9900" dirty="0"/>
           </a:p>
         </p:txBody>
       </p:sp>
@@ -1961,29 +2244,73 @@
         </p:nvSpPr>
         <p:spPr>
           <a:xfrm>
-            <a:off x="1238250" y="4846886"/>
-            <a:ext cx="2409825" cy="392311"/>
-          </a:xfrm>
-          <a:prstGeom prst="rect">
-            <a:avLst/>
-          </a:prstGeom>
-          <a:noFill/>
-          <a:ln/>
-        </p:spPr>
-        <p:txBody>
-          <a:bodyPr wrap="square" lIns="25400" tIns="25400" rIns="25400" bIns="25400" rtlCol="0" anchor="t">
-            <a:normAutofit lnSpcReduction="10000"/>
-          </a:bodyPr>
-          <a:lstStyle/>
-          <a:p>
-            <a:pPr marL="0" indent="0" algn="l">
-              <a:lnSpc>
-                <a:spcPct val="137778"/>
-              </a:lnSpc>
-              <a:buNone/>
-            </a:pPr>
-            <a:r>
-              <a:rPr lang="en-US" sz="1800" kern="0" spc="252" dirty="0">
+            <a:off x="1238250" y="5688731"/>
+            <a:ext cx="15716250" cy="687586"/>
+          </a:xfrm>
+          <a:prstGeom prst="rect">
+            <a:avLst/>
+          </a:prstGeom>
+          <a:noFill/>
+          <a:ln/>
+        </p:spPr>
+        <p:txBody>
+          <a:bodyPr wrap="square" lIns="25400" tIns="25400" rIns="25400" bIns="25400" rtlCol="0" anchor="t">
+            <a:normAutofit/>
+          </a:bodyPr>
+          <a:lstStyle/>
+          <a:p>
+            <a:pPr marL="0" indent="0" algn="l">
+              <a:lnSpc>
+                <a:spcPct val="136400"/>
+              </a:lnSpc>
+              <a:buNone/>
+            </a:pPr>
+            <a:r>
+              <a:rPr lang="en-US" sz="3300" i="1" dirty="0">
+                <a:solidFill>
+                  <a:srgbClr val="B9B0A2"/>
+                </a:solidFill>
+                <a:latin typeface="Georgia" pitchFamily="34" charset="0"/>
+                <a:ea typeface="Georgia" pitchFamily="34" charset="-122"/>
+                <a:cs typeface="Georgia" pitchFamily="34" charset="-120"/>
+              </a:rPr>
+              <a:t>Seeing attrition before the resignation letter.</a:t>
+            </a:r>
+            <a:endParaRPr lang="en-US" sz="3300" dirty="0"/>
+          </a:p>
+        </p:txBody>
+      </p:sp>
+      <p:sp>
+        <p:nvSpPr>
+          <p:cNvPr id="4" name="Text 2"/>
+          <p:cNvSpPr/>
+          <p:nvPr/>
+        </p:nvSpPr>
+        <p:spPr>
+          <a:xfrm>
+            <a:off x="1238250" y="7042099"/>
+            <a:ext cx="15716250" cy="451396"/>
+          </a:xfrm>
+          <a:prstGeom prst="rect">
+            <a:avLst/>
+          </a:prstGeom>
+          <a:noFill/>
+          <a:ln/>
+        </p:spPr>
+        <p:txBody>
+          <a:bodyPr wrap="square" lIns="25400" tIns="25400" rIns="25400" bIns="25400" rtlCol="0" anchor="t">
+            <a:normAutofit/>
+          </a:bodyPr>
+          <a:lstStyle/>
+          <a:p>
+            <a:pPr marL="0" indent="0" algn="l">
+              <a:lnSpc>
+                <a:spcPct val="135625"/>
+              </a:lnSpc>
+              <a:buNone/>
+            </a:pPr>
+            <a:r>
+              <a:rPr lang="en-US" sz="2100" kern="0" spc="210" dirty="0">
                 <a:solidFill>
                   <a:srgbClr val="7D8899"/>
                 </a:solidFill>
@@ -1991,235 +2318,15 @@
                 <a:ea typeface="Georgia" pitchFamily="34" charset="-122"/>
                 <a:cs typeface="Georgia" pitchFamily="34" charset="-120"/>
               </a:rPr>
-              <a:t>AUDIENCE</a:t>
-            </a:r>
-            <a:endParaRPr lang="en-US" sz="1800" dirty="0"/>
-          </a:p>
-        </p:txBody>
-      </p:sp>
-      <p:sp>
-        <p:nvSpPr>
-          <p:cNvPr id="4" name="Text 2"/>
-          <p:cNvSpPr/>
-          <p:nvPr/>
-        </p:nvSpPr>
-        <p:spPr>
-          <a:xfrm>
-            <a:off x="3886200" y="4732586"/>
-            <a:ext cx="7588002" cy="526703"/>
-          </a:xfrm>
-          <a:prstGeom prst="rect">
-            <a:avLst/>
-          </a:prstGeom>
-          <a:noFill/>
-          <a:ln/>
-        </p:spPr>
-        <p:txBody>
-          <a:bodyPr wrap="square" lIns="25400" tIns="25400" rIns="25400" bIns="25400" rtlCol="0" anchor="t">
-            <a:normAutofit lnSpcReduction="10000"/>
-          </a:bodyPr>
-          <a:lstStyle/>
-          <a:p>
-            <a:pPr marL="0" indent="0" algn="l">
-              <a:lnSpc>
-                <a:spcPct val="119302"/>
-              </a:lnSpc>
-              <a:buNone/>
-            </a:pPr>
-            <a:r>
-              <a:rPr lang="en-US" sz="2850" dirty="0">
-                <a:solidFill>
-                  <a:srgbClr val="F2EDE4"/>
-                </a:solidFill>
-                <a:latin typeface="Georgia" pitchFamily="34" charset="0"/>
-                <a:ea typeface="Georgia" pitchFamily="34" charset="-122"/>
-                <a:cs typeface="Georgia" pitchFamily="34" charset="-120"/>
-              </a:rPr>
-              <a:t>Executive committee, Helix Systems Group</a:t>
-            </a:r>
-            <a:endParaRPr lang="en-US" sz="2850" dirty="0"/>
+              <a:t>PHILIP WOUTER ROOS</a:t>
+            </a:r>
+            <a:endParaRPr lang="en-US" sz="2100" dirty="0"/>
           </a:p>
         </p:txBody>
       </p:sp>
       <p:sp>
         <p:nvSpPr>
           <p:cNvPr id="5" name="Text 3"/>
-          <p:cNvSpPr/>
-          <p:nvPr/>
-        </p:nvSpPr>
-        <p:spPr>
-          <a:xfrm>
-            <a:off x="1238250" y="5754588"/>
-            <a:ext cx="2409825" cy="392311"/>
-          </a:xfrm>
-          <a:prstGeom prst="rect">
-            <a:avLst/>
-          </a:prstGeom>
-          <a:noFill/>
-          <a:ln/>
-        </p:spPr>
-        <p:txBody>
-          <a:bodyPr wrap="square" lIns="25400" tIns="25400" rIns="25400" bIns="25400" rtlCol="0" anchor="t">
-            <a:normAutofit lnSpcReduction="10000"/>
-          </a:bodyPr>
-          <a:lstStyle/>
-          <a:p>
-            <a:pPr marL="0" indent="0" algn="l">
-              <a:lnSpc>
-                <a:spcPct val="137778"/>
-              </a:lnSpc>
-              <a:buNone/>
-            </a:pPr>
-            <a:r>
-              <a:rPr lang="en-US" sz="1800" kern="0" spc="252" dirty="0">
-                <a:solidFill>
-                  <a:srgbClr val="7D8899"/>
-                </a:solidFill>
-                <a:latin typeface="Georgia" pitchFamily="34" charset="0"/>
-                <a:ea typeface="Georgia" pitchFamily="34" charset="-122"/>
-                <a:cs typeface="Georgia" pitchFamily="34" charset="-120"/>
-              </a:rPr>
-              <a:t>OCCASION</a:t>
-            </a:r>
-            <a:endParaRPr lang="en-US" sz="1800" dirty="0"/>
-          </a:p>
-        </p:txBody>
-      </p:sp>
-      <p:sp>
-        <p:nvSpPr>
-          <p:cNvPr id="6" name="Text 4"/>
-          <p:cNvSpPr/>
-          <p:nvPr/>
-        </p:nvSpPr>
-        <p:spPr>
-          <a:xfrm>
-            <a:off x="3886200" y="5640288"/>
-            <a:ext cx="7176433" cy="526703"/>
-          </a:xfrm>
-          <a:prstGeom prst="rect">
-            <a:avLst/>
-          </a:prstGeom>
-          <a:noFill/>
-          <a:ln/>
-        </p:spPr>
-        <p:txBody>
-          <a:bodyPr wrap="square" lIns="25400" tIns="25400" rIns="25400" bIns="25400" rtlCol="0" anchor="t">
-            <a:normAutofit lnSpcReduction="10000"/>
-          </a:bodyPr>
-          <a:lstStyle/>
-          <a:p>
-            <a:pPr marL="0" indent="0" algn="l">
-              <a:lnSpc>
-                <a:spcPct val="119302"/>
-              </a:lnSpc>
-              <a:buNone/>
-            </a:pPr>
-            <a:r>
-              <a:rPr lang="en-US" sz="2850" dirty="0">
-                <a:solidFill>
-                  <a:srgbClr val="F2EDE4"/>
-                </a:solidFill>
-                <a:latin typeface="Georgia" pitchFamily="34" charset="0"/>
-                <a:ea typeface="Georgia" pitchFamily="34" charset="-122"/>
-                <a:cs typeface="Georgia" pitchFamily="34" charset="-120"/>
-              </a:rPr>
-              <a:t>Ten-minute investment decision briefing</a:t>
-            </a:r>
-            <a:endParaRPr lang="en-US" sz="2850" dirty="0"/>
-          </a:p>
-        </p:txBody>
-      </p:sp>
-      <p:sp>
-        <p:nvSpPr>
-          <p:cNvPr id="7" name="Text 5"/>
-          <p:cNvSpPr/>
-          <p:nvPr/>
-        </p:nvSpPr>
-        <p:spPr>
-          <a:xfrm>
-            <a:off x="1238250" y="6662291"/>
-            <a:ext cx="2409825" cy="392311"/>
-          </a:xfrm>
-          <a:prstGeom prst="rect">
-            <a:avLst/>
-          </a:prstGeom>
-          <a:noFill/>
-          <a:ln/>
-        </p:spPr>
-        <p:txBody>
-          <a:bodyPr wrap="square" lIns="25400" tIns="25400" rIns="25400" bIns="25400" rtlCol="0" anchor="t">
-            <a:normAutofit lnSpcReduction="10000"/>
-          </a:bodyPr>
-          <a:lstStyle/>
-          <a:p>
-            <a:pPr marL="0" indent="0" algn="l">
-              <a:lnSpc>
-                <a:spcPct val="137778"/>
-              </a:lnSpc>
-              <a:buNone/>
-            </a:pPr>
-            <a:r>
-              <a:rPr lang="en-US" sz="1800" kern="0" spc="252" dirty="0">
-                <a:solidFill>
-                  <a:srgbClr val="7D8899"/>
-                </a:solidFill>
-                <a:latin typeface="Georgia" pitchFamily="34" charset="0"/>
-                <a:ea typeface="Georgia" pitchFamily="34" charset="-122"/>
-                <a:cs typeface="Georgia" pitchFamily="34" charset="-120"/>
-              </a:rPr>
-              <a:t>THE ASK</a:t>
-            </a:r>
-            <a:endParaRPr lang="en-US" sz="1800" dirty="0"/>
-          </a:p>
-        </p:txBody>
-      </p:sp>
-      <p:sp>
-        <p:nvSpPr>
-          <p:cNvPr id="8" name="Text 6"/>
-          <p:cNvSpPr/>
-          <p:nvPr/>
-        </p:nvSpPr>
-        <p:spPr>
-          <a:xfrm>
-            <a:off x="3886200" y="6547991"/>
-            <a:ext cx="6610320" cy="526703"/>
-          </a:xfrm>
-          <a:prstGeom prst="rect">
-            <a:avLst/>
-          </a:prstGeom>
-          <a:noFill/>
-          <a:ln/>
-        </p:spPr>
-        <p:txBody>
-          <a:bodyPr wrap="square" lIns="25400" tIns="25400" rIns="25400" bIns="25400" rtlCol="0" anchor="t">
-            <a:normAutofit lnSpcReduction="10000"/>
-          </a:bodyPr>
-          <a:lstStyle/>
-          <a:p>
-            <a:pPr marL="0" indent="0" algn="l">
-              <a:lnSpc>
-                <a:spcPct val="119302"/>
-              </a:lnSpc>
-              <a:buNone/>
-            </a:pPr>
-            <a:r>
-              <a:rPr lang="en-US" sz="2850" dirty="0">
-                <a:solidFill>
-                  <a:srgbClr val="F2EDE4"/>
-                </a:solidFill>
-                <a:latin typeface="Georgia" pitchFamily="34" charset="0"/>
-                <a:ea typeface="Georgia" pitchFamily="34" charset="-122"/>
-                <a:cs typeface="Georgia" pitchFamily="34" charset="-120"/>
-              </a:rPr>
-              <a:t>$185,000 for a gated proof of concept</a:t>
-            </a:r>
-            <a:endParaRPr lang="en-US" sz="2850" dirty="0"/>
-          </a:p>
-        </p:txBody>
-      </p:sp>
-      <p:sp>
-        <p:nvSpPr>
-          <p:cNvPr id="9" name="Text 7"/>
           <p:cNvSpPr/>
           <p:nvPr/>
         </p:nvSpPr>
@@ -2263,14 +2370,14 @@
       </p:sp>
       <p:sp>
         <p:nvSpPr>
-          <p:cNvPr id="10" name="Text 8"/>
+          <p:cNvPr id="6" name="Text 4"/>
           <p:cNvSpPr/>
           <p:nvPr/>
         </p:nvSpPr>
         <p:spPr>
           <a:xfrm>
             <a:off x="16794956" y="9208889"/>
-            <a:ext cx="330994" cy="392311"/>
+            <a:ext cx="514250" cy="392311"/>
           </a:xfrm>
           <a:prstGeom prst="rect">
             <a:avLst/>
@@ -2299,7 +2406,7 @@
                 <a:ea typeface="Georgia" pitchFamily="34" charset="-122"/>
                 <a:cs typeface="Georgia" pitchFamily="34" charset="-120"/>
               </a:rPr>
-              <a:t>01</a:t>
+              <a:t>02</a:t>
             </a:r>
             <a:endParaRPr lang="en-US" sz="1800" dirty="0"/>
           </a:p>
@@ -5948,7 +6055,7 @@
 
 <file path=ppt/slides/slide2.xml><?xml version="1.0" encoding="utf-8"?>
 <p:sld xmlns:a="http://schemas.openxmlformats.org/drawingml/2006/main" xmlns:r="http://schemas.openxmlformats.org/officeDocument/2006/relationships" xmlns:p="http://schemas.openxmlformats.org/presentationml/2006/main">
-  <p:cSld name="Slide 2">
+  <p:cSld name="Slide 1">
     <p:bg>
       <p:bgPr>
         <a:solidFill>
@@ -5979,8 +6086,8 @@
         </p:nvSpPr>
         <p:spPr>
           <a:xfrm>
-            <a:off x="1238250" y="2076450"/>
-            <a:ext cx="14716125" cy="2602706"/>
+            <a:off x="1238250" y="1047750"/>
+            <a:ext cx="17392650" cy="750540"/>
           </a:xfrm>
           <a:prstGeom prst="rect">
             <a:avLst/>
@@ -5996,12 +6103,12 @@
           <a:p>
             <a:pPr marL="0" indent="0" algn="l">
               <a:lnSpc>
-                <a:spcPct val="89760"/>
-              </a:lnSpc>
-              <a:buNone/>
-            </a:pPr>
-            <a:r>
-              <a:rPr lang="en-US" sz="9900" kern="0" spc="-247" dirty="0">
+                <a:spcPct val="97143"/>
+              </a:lnSpc>
+              <a:buNone/>
+            </a:pPr>
+            <a:r>
+              <a:rPr lang="en-US" sz="5100" kern="0" spc="-51" dirty="0">
                 <a:solidFill>
                   <a:srgbClr val="F2EDE4"/>
                 </a:solidFill>
@@ -6009,9 +6116,9 @@
                 <a:ea typeface="Georgia" pitchFamily="34" charset="-122"/>
                 <a:cs typeface="Georgia" pitchFamily="34" charset="-120"/>
               </a:rPr>
-              <a:t>The Employee Retention Predictor</a:t>
-            </a:r>
-            <a:endParaRPr lang="en-US" sz="9900" dirty="0"/>
+              <a:t>Context &amp; Objective</a:t>
+            </a:r>
+            <a:endParaRPr lang="en-US" sz="5100" dirty="0"/>
           </a:p>
         </p:txBody>
       </p:sp>
@@ -6023,39 +6130,39 @@
         </p:nvSpPr>
         <p:spPr>
           <a:xfrm>
-            <a:off x="1238250" y="5688731"/>
-            <a:ext cx="15716250" cy="687586"/>
-          </a:xfrm>
-          <a:prstGeom prst="rect">
-            <a:avLst/>
-          </a:prstGeom>
-          <a:noFill/>
-          <a:ln/>
-        </p:spPr>
-        <p:txBody>
-          <a:bodyPr wrap="square" lIns="25400" tIns="25400" rIns="25400" bIns="25400" rtlCol="0" anchor="t">
-            <a:normAutofit/>
-          </a:bodyPr>
-          <a:lstStyle/>
-          <a:p>
-            <a:pPr marL="0" indent="0" algn="l">
-              <a:lnSpc>
-                <a:spcPct val="136400"/>
-              </a:lnSpc>
-              <a:buNone/>
-            </a:pPr>
-            <a:r>
-              <a:rPr lang="en-US" sz="3300" i="1" dirty="0">
-                <a:solidFill>
-                  <a:srgbClr val="B9B0A2"/>
-                </a:solidFill>
-                <a:latin typeface="Georgia" pitchFamily="34" charset="0"/>
-                <a:ea typeface="Georgia" pitchFamily="34" charset="-122"/>
-                <a:cs typeface="Georgia" pitchFamily="34" charset="-120"/>
-              </a:rPr>
-              <a:t>Seeing attrition before the resignation letter.</a:t>
-            </a:r>
-            <a:endParaRPr lang="en-US" sz="3300" dirty="0"/>
+            <a:off x="1238250" y="4846886"/>
+            <a:ext cx="2409825" cy="392311"/>
+          </a:xfrm>
+          <a:prstGeom prst="rect">
+            <a:avLst/>
+          </a:prstGeom>
+          <a:noFill/>
+          <a:ln/>
+        </p:spPr>
+        <p:txBody>
+          <a:bodyPr wrap="square" lIns="25400" tIns="25400" rIns="25400" bIns="25400" rtlCol="0" anchor="t">
+            <a:normAutofit lnSpcReduction="10000"/>
+          </a:bodyPr>
+          <a:lstStyle/>
+          <a:p>
+            <a:pPr marL="0" indent="0" algn="l">
+              <a:lnSpc>
+                <a:spcPct val="137778"/>
+              </a:lnSpc>
+              <a:buNone/>
+            </a:pPr>
+            <a:r>
+              <a:rPr lang="en-US" sz="1800" kern="0" spc="252" dirty="0">
+                <a:solidFill>
+                  <a:srgbClr val="7D8899"/>
+                </a:solidFill>
+                <a:latin typeface="Georgia" pitchFamily="34" charset="0"/>
+                <a:ea typeface="Georgia" pitchFamily="34" charset="-122"/>
+                <a:cs typeface="Georgia" pitchFamily="34" charset="-120"/>
+              </a:rPr>
+              <a:t>AUDIENCE</a:t>
+            </a:r>
+            <a:endParaRPr lang="en-US" sz="1800" dirty="0"/>
           </a:p>
         </p:txBody>
       </p:sp>
@@ -6067,29 +6174,73 @@
         </p:nvSpPr>
         <p:spPr>
           <a:xfrm>
-            <a:off x="1238250" y="7042099"/>
-            <a:ext cx="15716250" cy="451396"/>
-          </a:xfrm>
-          <a:prstGeom prst="rect">
-            <a:avLst/>
-          </a:prstGeom>
-          <a:noFill/>
-          <a:ln/>
-        </p:spPr>
-        <p:txBody>
-          <a:bodyPr wrap="square" lIns="25400" tIns="25400" rIns="25400" bIns="25400" rtlCol="0" anchor="t">
-            <a:normAutofit/>
-          </a:bodyPr>
-          <a:lstStyle/>
-          <a:p>
-            <a:pPr marL="0" indent="0" algn="l">
-              <a:lnSpc>
-                <a:spcPct val="135625"/>
-              </a:lnSpc>
-              <a:buNone/>
-            </a:pPr>
-            <a:r>
-              <a:rPr lang="en-US" sz="2100" kern="0" spc="210" dirty="0">
+            <a:off x="3886200" y="4732586"/>
+            <a:ext cx="7588002" cy="526703"/>
+          </a:xfrm>
+          <a:prstGeom prst="rect">
+            <a:avLst/>
+          </a:prstGeom>
+          <a:noFill/>
+          <a:ln/>
+        </p:spPr>
+        <p:txBody>
+          <a:bodyPr wrap="square" lIns="25400" tIns="25400" rIns="25400" bIns="25400" rtlCol="0" anchor="t">
+            <a:normAutofit lnSpcReduction="10000"/>
+          </a:bodyPr>
+          <a:lstStyle/>
+          <a:p>
+            <a:pPr marL="0" indent="0" algn="l">
+              <a:lnSpc>
+                <a:spcPct val="119302"/>
+              </a:lnSpc>
+              <a:buNone/>
+            </a:pPr>
+            <a:r>
+              <a:rPr lang="en-US" sz="2850" dirty="0">
+                <a:solidFill>
+                  <a:srgbClr val="F2EDE4"/>
+                </a:solidFill>
+                <a:latin typeface="Georgia" pitchFamily="34" charset="0"/>
+                <a:ea typeface="Georgia" pitchFamily="34" charset="-122"/>
+                <a:cs typeface="Georgia" pitchFamily="34" charset="-120"/>
+              </a:rPr>
+              <a:t>Executive committee, Helix Systems Group</a:t>
+            </a:r>
+            <a:endParaRPr lang="en-US" sz="2850" dirty="0"/>
+          </a:p>
+        </p:txBody>
+      </p:sp>
+      <p:sp>
+        <p:nvSpPr>
+          <p:cNvPr id="5" name="Text 3"/>
+          <p:cNvSpPr/>
+          <p:nvPr/>
+        </p:nvSpPr>
+        <p:spPr>
+          <a:xfrm>
+            <a:off x="1238250" y="5754588"/>
+            <a:ext cx="2409825" cy="392311"/>
+          </a:xfrm>
+          <a:prstGeom prst="rect">
+            <a:avLst/>
+          </a:prstGeom>
+          <a:noFill/>
+          <a:ln/>
+        </p:spPr>
+        <p:txBody>
+          <a:bodyPr wrap="square" lIns="25400" tIns="25400" rIns="25400" bIns="25400" rtlCol="0" anchor="t">
+            <a:normAutofit lnSpcReduction="10000"/>
+          </a:bodyPr>
+          <a:lstStyle/>
+          <a:p>
+            <a:pPr marL="0" indent="0" algn="l">
+              <a:lnSpc>
+                <a:spcPct val="137778"/>
+              </a:lnSpc>
+              <a:buNone/>
+            </a:pPr>
+            <a:r>
+              <a:rPr lang="en-US" sz="1800" kern="0" spc="252" dirty="0">
                 <a:solidFill>
                   <a:srgbClr val="7D8899"/>
                 </a:solidFill>
@@ -6097,15 +6248,147 @@
                 <a:ea typeface="Georgia" pitchFamily="34" charset="-122"/>
                 <a:cs typeface="Georgia" pitchFamily="34" charset="-120"/>
               </a:rPr>
-              <a:t>PHILIP WOUTER ROOS</a:t>
-            </a:r>
-            <a:endParaRPr lang="en-US" sz="2100" dirty="0"/>
-          </a:p>
-        </p:txBody>
-      </p:sp>
-      <p:sp>
-        <p:nvSpPr>
-          <p:cNvPr id="5" name="Text 3"/>
+              <a:t>OCCASION</a:t>
+            </a:r>
+            <a:endParaRPr lang="en-US" sz="1800" dirty="0"/>
+          </a:p>
+        </p:txBody>
+      </p:sp>
+      <p:sp>
+        <p:nvSpPr>
+          <p:cNvPr id="6" name="Text 4"/>
+          <p:cNvSpPr/>
+          <p:nvPr/>
+        </p:nvSpPr>
+        <p:spPr>
+          <a:xfrm>
+            <a:off x="3886200" y="5640288"/>
+            <a:ext cx="7176433" cy="526703"/>
+          </a:xfrm>
+          <a:prstGeom prst="rect">
+            <a:avLst/>
+          </a:prstGeom>
+          <a:noFill/>
+          <a:ln/>
+        </p:spPr>
+        <p:txBody>
+          <a:bodyPr wrap="square" lIns="25400" tIns="25400" rIns="25400" bIns="25400" rtlCol="0" anchor="t">
+            <a:normAutofit lnSpcReduction="10000"/>
+          </a:bodyPr>
+          <a:lstStyle/>
+          <a:p>
+            <a:pPr marL="0" indent="0" algn="l">
+              <a:lnSpc>
+                <a:spcPct val="119302"/>
+              </a:lnSpc>
+              <a:buNone/>
+            </a:pPr>
+            <a:r>
+              <a:rPr lang="en-US" sz="2850" dirty="0">
+                <a:solidFill>
+                  <a:srgbClr val="F2EDE4"/>
+                </a:solidFill>
+                <a:latin typeface="Georgia" pitchFamily="34" charset="0"/>
+                <a:ea typeface="Georgia" pitchFamily="34" charset="-122"/>
+                <a:cs typeface="Georgia" pitchFamily="34" charset="-120"/>
+              </a:rPr>
+              <a:t>Ten-minute investment decision briefing</a:t>
+            </a:r>
+            <a:endParaRPr lang="en-US" sz="2850" dirty="0"/>
+          </a:p>
+        </p:txBody>
+      </p:sp>
+      <p:sp>
+        <p:nvSpPr>
+          <p:cNvPr id="7" name="Text 5"/>
+          <p:cNvSpPr/>
+          <p:nvPr/>
+        </p:nvSpPr>
+        <p:spPr>
+          <a:xfrm>
+            <a:off x="1238250" y="6662291"/>
+            <a:ext cx="2409825" cy="392311"/>
+          </a:xfrm>
+          <a:prstGeom prst="rect">
+            <a:avLst/>
+          </a:prstGeom>
+          <a:noFill/>
+          <a:ln/>
+        </p:spPr>
+        <p:txBody>
+          <a:bodyPr wrap="square" lIns="25400" tIns="25400" rIns="25400" bIns="25400" rtlCol="0" anchor="t">
+            <a:normAutofit lnSpcReduction="10000"/>
+          </a:bodyPr>
+          <a:lstStyle/>
+          <a:p>
+            <a:pPr marL="0" indent="0" algn="l">
+              <a:lnSpc>
+                <a:spcPct val="137778"/>
+              </a:lnSpc>
+              <a:buNone/>
+            </a:pPr>
+            <a:r>
+              <a:rPr lang="en-US" sz="1800" kern="0" spc="252" dirty="0">
+                <a:solidFill>
+                  <a:srgbClr val="7D8899"/>
+                </a:solidFill>
+                <a:latin typeface="Georgia" pitchFamily="34" charset="0"/>
+                <a:ea typeface="Georgia" pitchFamily="34" charset="-122"/>
+                <a:cs typeface="Georgia" pitchFamily="34" charset="-120"/>
+              </a:rPr>
+              <a:t>THE ASK</a:t>
+            </a:r>
+            <a:endParaRPr lang="en-US" sz="1800" dirty="0"/>
+          </a:p>
+        </p:txBody>
+      </p:sp>
+      <p:sp>
+        <p:nvSpPr>
+          <p:cNvPr id="8" name="Text 6"/>
+          <p:cNvSpPr/>
+          <p:nvPr/>
+        </p:nvSpPr>
+        <p:spPr>
+          <a:xfrm>
+            <a:off x="3886200" y="6547991"/>
+            <a:ext cx="6610320" cy="526703"/>
+          </a:xfrm>
+          <a:prstGeom prst="rect">
+            <a:avLst/>
+          </a:prstGeom>
+          <a:noFill/>
+          <a:ln/>
+        </p:spPr>
+        <p:txBody>
+          <a:bodyPr wrap="square" lIns="25400" tIns="25400" rIns="25400" bIns="25400" rtlCol="0" anchor="t">
+            <a:normAutofit lnSpcReduction="10000"/>
+          </a:bodyPr>
+          <a:lstStyle/>
+          <a:p>
+            <a:pPr marL="0" indent="0" algn="l">
+              <a:lnSpc>
+                <a:spcPct val="119302"/>
+              </a:lnSpc>
+              <a:buNone/>
+            </a:pPr>
+            <a:r>
+              <a:rPr lang="en-US" sz="2850" dirty="0">
+                <a:solidFill>
+                  <a:srgbClr val="F2EDE4"/>
+                </a:solidFill>
+                <a:latin typeface="Georgia" pitchFamily="34" charset="0"/>
+                <a:ea typeface="Georgia" pitchFamily="34" charset="-122"/>
+                <a:cs typeface="Georgia" pitchFamily="34" charset="-120"/>
+              </a:rPr>
+              <a:t>$185,000 for a gated proof of concept</a:t>
+            </a:r>
+            <a:endParaRPr lang="en-US" sz="2850" dirty="0"/>
+          </a:p>
+        </p:txBody>
+      </p:sp>
+      <p:sp>
+        <p:nvSpPr>
+          <p:cNvPr id="9" name="Text 7"/>
           <p:cNvSpPr/>
           <p:nvPr/>
         </p:nvSpPr>
@@ -6149,14 +6432,14 @@
       </p:sp>
       <p:sp>
         <p:nvSpPr>
-          <p:cNvPr id="6" name="Text 4"/>
+          <p:cNvPr id="10" name="Text 8"/>
           <p:cNvSpPr/>
           <p:nvPr/>
         </p:nvSpPr>
         <p:spPr>
           <a:xfrm>
             <a:off x="16794956" y="9208889"/>
-            <a:ext cx="514250" cy="392311"/>
+            <a:ext cx="330994" cy="392311"/>
           </a:xfrm>
           <a:prstGeom prst="rect">
             <a:avLst/>
@@ -6185,7 +6468,7 @@
                 <a:ea typeface="Georgia" pitchFamily="34" charset="-122"/>
                 <a:cs typeface="Georgia" pitchFamily="34" charset="-120"/>
               </a:rPr>
-              <a:t>02</a:t>
+              <a:t>01</a:t>
             </a:r>
             <a:endParaRPr lang="en-US" sz="1800" dirty="0"/>
           </a:p>
@@ -10282,7 +10565,7 @@
                 <a:ea typeface="Georgia" pitchFamily="34" charset="-122"/>
                 <a:cs typeface="Georgia" pitchFamily="34" charset="-120"/>
               </a:rPr>
-              <a:t>Cost of fairness: 0.02 AUC. Worth it.</a:t>
+              <a:t>Cost of fairness: 0.011 AUC. Worth it.</a:t>
             </a:r>
             <a:endParaRPr lang="en-US" sz="2400" dirty="0"/>
           </a:p>

</xml_diff>